<commit_message>
Put a box saying what is missing where a slide's chart, picture or shape cannot be drawn, including charts PPTXjs never draws and EMF and WMF pictures, which were blank, for #48
</commit_message>
<xml_diff>
--- a/tests/fixtures/files/unreadable.pptx
+++ b/tests/fixtures/files/unreadable.pptx
@@ -2070,6 +2070,22 @@
           </a:p>
         </p:txBody>
       </p:sp>
+      <p:pic>
+        <p:nvPicPr>
+          <p:cNvPr id="52" name="Picture placeholder"/>
+          <p:cNvPicPr/>
+          <p:nvPr>
+            <p:ph type="pic" idx="13"/>
+          </p:nvPr>
+        </p:nvPicPr>
+        <p:blipFill/>
+        <p:spPr>
+          <a:xfrm>
+            <a:off x="5486400" y="457200"/>
+            <a:ext cx="914400" cy="914400"/>
+          </a:xfrm>
+        </p:spPr>
+      </p:pic>
     </p:spTree>
     <p:extLst>
       <p:ext uri="{BB962C8B-B14F-4D97-AF65-F5344CB8AC3E}">
@@ -3235,6 +3251,50 @@
           <a:p>
             <a:r>
               <a:t>The slide after it</a:t>
+            </a:r>
+          </a:p>
+        </p:txBody>
+      </p:sp>
+      <p:sp>
+        <p:nvSpPr>
+          <p:cNvPr id="60" name="Shaded, no text"/>
+          <p:cNvSpPr/>
+          <p:nvPr/>
+        </p:nvSpPr>
+        <p:spPr>
+          <a:xfrm>
+            <a:off x="914400" y="1828800"/>
+            <a:ext cx="1828800" cy="914400"/>
+          </a:xfrm>
+          <a:prstGeom prst="rect">
+            <a:avLst/>
+          </a:prstGeom>
+          <a:gradFill/>
+        </p:spPr>
+      </p:sp>
+      <p:sp>
+        <p:nvSpPr>
+          <p:cNvPr id="61" name="Shaded, with text"/>
+          <p:cNvSpPr/>
+          <p:nvPr/>
+        </p:nvSpPr>
+        <p:spPr>
+          <a:xfrm>
+            <a:off x="4572000" y="1828800"/>
+            <a:ext cx="2743200" cy="914400"/>
+          </a:xfrm>
+          <a:prstGeom prst="rect">
+            <a:avLst/>
+          </a:prstGeom>
+          <a:gradFill/>
+        </p:spPr>
+        <p:txBody>
+          <a:bodyPr/>
+          <a:lstStyle/>
+          <a:p>
+            <a:r>
+              <a:rPr lang="en-US" sz="1800"/>
+              <a:t>Words in a shaded box</a:t>
             </a:r>
           </a:p>
         </p:txBody>

</xml_diff>